<commit_message>
Finalize deck: team Handsome Squidward (Aditya, Ruhani)
Set TEAM and add MEMBERS on the title and close slides; add the
copy-paste submission-form answers doc.

Co-Authored-By: Claude Opus 4.8 <noreply@anthropic.com>
</commit_message>
<xml_diff>
--- a/artifacts/PITWALL_TrackShift2026.pptx
+++ b/artifacts/PITWALL_TrackShift2026.pptx
@@ -3337,8 +3337,8 @@
         </p:nvSpPr>
         <p:spPr>
           <a:xfrm>
-            <a:off x="1097280" y="5806440"/>
-            <a:ext cx="10515600" cy="822960"/>
+            <a:off x="1097280" y="5669280"/>
+            <a:ext cx="10515600" cy="1005840"/>
           </a:xfrm>
           <a:prstGeom prst="rect">
             <a:avLst/>
@@ -3359,17 +3359,39 @@
                 <a:spcPts val="0"/>
               </a:spcBef>
               <a:spcAft>
+                <a:spcPts val="300"/>
+              </a:spcAft>
+            </a:pPr>
+            <a:r>
+              <a:rPr sz="1250" b="0" i="0">
+                <a:solidFill>
+                  <a:srgbClr val="C5CBD1"/>
+                </a:solidFill>
+                <a:latin typeface="Segoe UI"/>
+              </a:rPr>
+              <a:t>AI Motorsport Intelligence   ·   Tyre Degradation Intelligence</a:t>
+            </a:r>
+          </a:p>
+          <a:p>
+            <a:pPr algn="l">
+              <a:lnSpc>
+                <a:spcPct val="105000"/>
+              </a:lnSpc>
+              <a:spcBef>
+                <a:spcPts val="0"/>
+              </a:spcBef>
+              <a:spcAft>
                 <a:spcPts val="200"/>
               </a:spcAft>
             </a:pPr>
             <a:r>
-              <a:rPr sz="1250" b="0" i="0">
-                <a:solidFill>
-                  <a:srgbClr val="C5CBD1"/>
-                </a:solidFill>
-                <a:latin typeface="Segoe UI"/>
-              </a:rPr>
-              <a:t>AI Motorsport Intelligence   ·   Tyre Degradation Intelligence</a:t>
+              <a:rPr sz="1250" b="1" i="0">
+                <a:solidFill>
+                  <a:srgbClr val="0B6EA8"/>
+                </a:solidFill>
+                <a:latin typeface="Segoe UI"/>
+              </a:rPr>
+              <a:t>Team Handsome Squidward</a:t>
             </a:r>
           </a:p>
           <a:p>
@@ -3385,13 +3407,13 @@
               </a:spcAft>
             </a:pPr>
             <a:r>
-              <a:rPr sz="1250" b="1" i="0">
-                <a:solidFill>
-                  <a:srgbClr val="0B6EA8"/>
-                </a:solidFill>
-                <a:latin typeface="Segoe UI"/>
-              </a:rPr>
-              <a:t>Team ‹ your team name ›</a:t>
+              <a:rPr sz="1200" b="0" i="0">
+                <a:solidFill>
+                  <a:srgbClr val="9AA0A6"/>
+                </a:solidFill>
+                <a:latin typeface="Segoe UI"/>
+              </a:rPr>
+              <a:t>Aditya  ·  Ruhani</a:t>
             </a:r>
           </a:p>
         </p:txBody>
@@ -5269,8 +5291,8 @@
         </p:nvSpPr>
         <p:spPr>
           <a:xfrm>
-            <a:off x="1097280" y="5943600"/>
-            <a:ext cx="10058400" cy="548640"/>
+            <a:off x="1097280" y="5852160"/>
+            <a:ext cx="10515600" cy="822960"/>
           </a:xfrm>
           <a:prstGeom prst="rect">
             <a:avLst/>
@@ -5291,17 +5313,39 @@
                 <a:spcPts val="0"/>
               </a:spcBef>
               <a:spcAft>
-                <a:spcPts val="0"/>
+                <a:spcPts val="300"/>
               </a:spcAft>
             </a:pPr>
             <a:r>
               <a:rPr sz="1300" b="0" i="0">
                 <a:solidFill>
+                  <a:srgbClr val="C5CBD1"/>
+                </a:solidFill>
+                <a:latin typeface="Segoe UI"/>
+              </a:rPr>
+              <a:t>Team Handsome Squidward   ·   Aditya  ·  Ruhani</a:t>
+            </a:r>
+          </a:p>
+          <a:p>
+            <a:pPr algn="l">
+              <a:lnSpc>
+                <a:spcPct val="105000"/>
+              </a:lnSpc>
+              <a:spcBef>
+                <a:spcPts val="0"/>
+              </a:spcBef>
+              <a:spcAft>
+                <a:spcPts val="0"/>
+              </a:spcAft>
+            </a:pPr>
+            <a:r>
+              <a:rPr sz="1200" b="0" i="0">
+                <a:solidFill>
                   <a:srgbClr val="9AA0A6"/>
                 </a:solidFill>
                 <a:latin typeface="Segoe UI"/>
               </a:rPr>
-              <a:t>Team ‹ your team name ›   ·   AI Motorsport Intelligence   ·   TrackShift 2026</a:t>
+              <a:t>AI Motorsport Intelligence   ·   TrackShift 2026</a:t>
             </a:r>
           </a:p>
         </p:txBody>

</xml_diff>